<commit_message>
fix: fix documentation e presentation
</commit_message>
<xml_diff>
--- a/ruggine_chat_presentazione.pptx
+++ b/ruggine_chat_presentazione.pptx
@@ -13638,7 +13638,7 @@
         </p:nvSpPr>
         <p:spPr>
           <a:xfrm>
-            <a:off x="4667250" y="1572964"/>
+            <a:off x="4667250" y="1372939"/>
             <a:ext cx="4177665" cy="400050"/>
           </a:xfrm>
           <a:prstGeom prst="rect">
@@ -13666,6 +13666,7 @@
               </a:defRPr>
             </a:pPr>
             <a:r>
+              <a:rPr dirty="0"/>
               <a:t>Multi-threaded Async Runtime</a:t>
             </a:r>
             <a:endParaRPr lang="en-US" sz="1050" dirty="0"/>
@@ -13682,17 +13683,115 @@
               </a:defRPr>
             </a:pPr>
             <a:r>
-              <a:t>Tokio è il motore asincrono che fa girare tutto il sistema, sia backend che frontend. Nel backend, ogni nuova connessione WebSocket crea tre task concorrenti che lavorano in parallelo: uno per scrivere messaggi al client, uno per leggere i suoi input, e uno per gestire le notifiche broadcast. Nel frontend, Tokio gestisce la connessione client verso il server usando tokio-tungstenite. Il sistema usa primitives come select! per gestire eventi multipli simultaneamente e interval per operazioni periodiche come gli heartbeat.</a:t>
-            </a:r>
+              <a:rPr lang="it-IT" sz="1300" dirty="0"/>
+              <a:t>Tokio è il motore asincrono che fa girare tutto il sistema, sia </a:t>
+            </a:r>
+            <a:r>
+              <a:rPr lang="it-IT" sz="1300" dirty="0" err="1"/>
+              <a:t>backend</a:t>
+            </a:r>
+            <a:r>
+              <a:rPr lang="it-IT" sz="1300" dirty="0"/>
+              <a:t> che </a:t>
+            </a:r>
+            <a:r>
+              <a:rPr lang="it-IT" sz="1300" dirty="0" err="1"/>
+              <a:t>frontend</a:t>
+            </a:r>
+            <a:r>
+              <a:rPr lang="it-IT" sz="1300" dirty="0"/>
+              <a:t>. Nel </a:t>
+            </a:r>
+            <a:r>
+              <a:rPr lang="it-IT" sz="1300" dirty="0" err="1"/>
+              <a:t>backend</a:t>
+            </a:r>
+            <a:r>
+              <a:rPr lang="it-IT" sz="1300" dirty="0"/>
+              <a:t>, ogni nuova connessione </a:t>
+            </a:r>
+            <a:r>
+              <a:rPr lang="it-IT" sz="1300" dirty="0" err="1"/>
+              <a:t>WebSocket</a:t>
+            </a:r>
+            <a:r>
+              <a:rPr lang="it-IT" sz="1300" dirty="0"/>
+              <a:t> crea tre task concorrenti che lavorano in parallelo: uno per scrivere messaggi al client, uno per leggere i suoi input, e uno per gestire le notifiche broadcast. Il </a:t>
+            </a:r>
+            <a:r>
+              <a:rPr lang="it-IT" sz="1300" dirty="0" err="1"/>
+              <a:t>Receiver</a:t>
+            </a:r>
+            <a:r>
+              <a:rPr lang="it-IT" sz="1300" dirty="0"/>
+              <a:t> </a:t>
+            </a:r>
+            <a:r>
+              <a:rPr lang="it-IT" sz="1300" dirty="0" err="1"/>
+              <a:t>spawna</a:t>
+            </a:r>
+            <a:r>
+              <a:rPr lang="it-IT" sz="1300" dirty="0"/>
+              <a:t> un task per ogni conversazione attiva dell'utente. Nel </a:t>
+            </a:r>
+            <a:r>
+              <a:rPr lang="it-IT" sz="1300" dirty="0" err="1"/>
+              <a:t>frontend</a:t>
+            </a:r>
+            <a:r>
+              <a:rPr lang="it-IT" sz="1300" dirty="0"/>
+              <a:t>, Tokio gestisce la connessione client verso il server usando </a:t>
+            </a:r>
+            <a:r>
+              <a:rPr lang="it-IT" sz="1300" dirty="0" err="1"/>
+              <a:t>tokio-tungstenite</a:t>
+            </a:r>
+            <a:r>
+              <a:rPr lang="it-IT" sz="1300" dirty="0"/>
+              <a:t>. Il sistema usa </a:t>
+            </a:r>
+            <a:r>
+              <a:rPr lang="it-IT" sz="1300" dirty="0" err="1"/>
+              <a:t>primitives</a:t>
+            </a:r>
+            <a:r>
+              <a:rPr lang="it-IT" sz="1300" dirty="0"/>
+              <a:t> come </a:t>
+            </a:r>
+            <a:r>
+              <a:rPr lang="it-IT" sz="1300" dirty="0" err="1"/>
+              <a:t>select</a:t>
+            </a:r>
+            <a:r>
+              <a:rPr lang="it-IT" sz="1300" dirty="0"/>
+              <a:t>! per gestire eventi multipli simultaneamente e </a:t>
+            </a:r>
+            <a:r>
+              <a:rPr lang="it-IT" sz="1300" dirty="0" err="1"/>
+              <a:t>interval</a:t>
+            </a:r>
+            <a:r>
+              <a:rPr lang="it-IT" sz="1300" dirty="0"/>
+              <a:t> per operazioni periodiche come gli </a:t>
+            </a:r>
+            <a:r>
+              <a:rPr lang="it-IT" sz="1300" dirty="0" err="1"/>
+              <a:t>heartbeat</a:t>
+            </a:r>
+            <a:r>
+              <a:rPr lang="it-IT" sz="1300" dirty="0"/>
+              <a:t>.</a:t>
+            </a:r>
+            <a:endParaRPr dirty="0"/>
           </a:p>
         </p:txBody>
       </p:sp>
       <p:pic>
         <p:nvPicPr>
-          <p:cNvPr id="22" name="Immagine 21">
+          <p:cNvPr id="6" name="Immagine 5" descr="Immagine che contiene testo, schermata, Carattere, documento&#10;&#10;Il contenuto generato dall'IA potrebbe non essere corretto.">
             <a:extLst>
               <a:ext uri="{FF2B5EF4-FFF2-40B4-BE49-F238E27FC236}">
-                <a16:creationId xmlns:a16="http://schemas.microsoft.com/office/drawing/2014/main" id="{C9C2DC0E-46A3-27E3-BC9D-26A5278E3313}"/>
+                <a16:creationId xmlns:a16="http://schemas.microsoft.com/office/drawing/2014/main" id="{D2BA32ED-D9FF-5E7E-EB05-C9ADA3FB5605}"/>
               </a:ext>
             </a:extLst>
           </p:cNvPr>
@@ -13709,8 +13808,8 @@
         </p:blipFill>
         <p:spPr>
           <a:xfrm>
-            <a:off x="698686" y="1252972"/>
-            <a:ext cx="2952382" cy="3191593"/>
+            <a:off x="686709" y="976616"/>
+            <a:ext cx="3020758" cy="3570536"/>
           </a:xfrm>
           <a:prstGeom prst="rect">
             <a:avLst/>

</xml_diff>